<commit_message>
Add KV cache & SWR to live-status API
Implement Cloudflare KV-backed caching for the live-status endpoint using a stale-while-revalidate pattern: add KV lookup, fresh/stale/miss handling, background refresh, KV TTL and robust origin fallback with CORS-aware JSON responses. Update client polling to use jittered setTimeout scheduling (replace fixed setInterval) and adjust global state key (fetchTimeout). Add wrangler.toml and .env.example notes for KV binding and local dev (wrangler pages dev --kv LIVE_STATUS_CACHE). Also include minor updates to bundled PDF/PPTX files.
</commit_message>
<xml_diff>
--- a/치지직 라이브 독 적용 방법.pptx
+++ b/치지직 라이브 독 적용 방법.pptx
@@ -6,6 +6,7 @@
   </p:sldMasterIdLst>
   <p:sldIdLst>
     <p:sldId id="256" r:id="rId2"/>
+    <p:sldId id="257" r:id="rId3"/>
   </p:sldIdLst>
   <p:sldSz cx="12192000" cy="6858000"/>
   <p:notesSz cx="6858000" cy="9144000"/>
@@ -104,6 +105,11 @@
       </a:defRPr>
     </a:lvl9pPr>
   </p:defaultTextStyle>
+  <p:extLst>
+    <p:ext uri="{EFAFB233-063F-42B5-8137-9DF3F51BA10A}">
+      <p15:sldGuideLst xmlns:p15="http://schemas.microsoft.com/office/powerpoint/2012/main"/>
+    </p:ext>
+  </p:extLst>
 </p:presentation>
 </file>
 
@@ -254,7 +260,7 @@
           <a:p>
             <a:fld id="{9021E875-82EE-4D84-97F4-14491609B700}" type="datetimeFigureOut">
               <a:rPr lang="ko-KR" altLang="en-US" smtClean="0"/>
-              <a:t>2026-03-23</a:t>
+              <a:t>2026-03-26</a:t>
             </a:fld>
             <a:endParaRPr lang="ko-KR" altLang="en-US"/>
           </a:p>
@@ -452,7 +458,7 @@
           <a:p>
             <a:fld id="{9021E875-82EE-4D84-97F4-14491609B700}" type="datetimeFigureOut">
               <a:rPr lang="ko-KR" altLang="en-US" smtClean="0"/>
-              <a:t>2026-03-23</a:t>
+              <a:t>2026-03-26</a:t>
             </a:fld>
             <a:endParaRPr lang="ko-KR" altLang="en-US"/>
           </a:p>
@@ -660,7 +666,7 @@
           <a:p>
             <a:fld id="{9021E875-82EE-4D84-97F4-14491609B700}" type="datetimeFigureOut">
               <a:rPr lang="ko-KR" altLang="en-US" smtClean="0"/>
-              <a:t>2026-03-23</a:t>
+              <a:t>2026-03-26</a:t>
             </a:fld>
             <a:endParaRPr lang="ko-KR" altLang="en-US"/>
           </a:p>
@@ -858,7 +864,7 @@
           <a:p>
             <a:fld id="{9021E875-82EE-4D84-97F4-14491609B700}" type="datetimeFigureOut">
               <a:rPr lang="ko-KR" altLang="en-US" smtClean="0"/>
-              <a:t>2026-03-23</a:t>
+              <a:t>2026-03-26</a:t>
             </a:fld>
             <a:endParaRPr lang="ko-KR" altLang="en-US"/>
           </a:p>
@@ -1133,7 +1139,7 @@
           <a:p>
             <a:fld id="{9021E875-82EE-4D84-97F4-14491609B700}" type="datetimeFigureOut">
               <a:rPr lang="ko-KR" altLang="en-US" smtClean="0"/>
-              <a:t>2026-03-23</a:t>
+              <a:t>2026-03-26</a:t>
             </a:fld>
             <a:endParaRPr lang="ko-KR" altLang="en-US"/>
           </a:p>
@@ -1398,7 +1404,7 @@
           <a:p>
             <a:fld id="{9021E875-82EE-4D84-97F4-14491609B700}" type="datetimeFigureOut">
               <a:rPr lang="ko-KR" altLang="en-US" smtClean="0"/>
-              <a:t>2026-03-23</a:t>
+              <a:t>2026-03-26</a:t>
             </a:fld>
             <a:endParaRPr lang="ko-KR" altLang="en-US"/>
           </a:p>
@@ -1810,7 +1816,7 @@
           <a:p>
             <a:fld id="{9021E875-82EE-4D84-97F4-14491609B700}" type="datetimeFigureOut">
               <a:rPr lang="ko-KR" altLang="en-US" smtClean="0"/>
-              <a:t>2026-03-23</a:t>
+              <a:t>2026-03-26</a:t>
             </a:fld>
             <a:endParaRPr lang="ko-KR" altLang="en-US"/>
           </a:p>
@@ -1951,7 +1957,7 @@
           <a:p>
             <a:fld id="{9021E875-82EE-4D84-97F4-14491609B700}" type="datetimeFigureOut">
               <a:rPr lang="ko-KR" altLang="en-US" smtClean="0"/>
-              <a:t>2026-03-23</a:t>
+              <a:t>2026-03-26</a:t>
             </a:fld>
             <a:endParaRPr lang="ko-KR" altLang="en-US"/>
           </a:p>
@@ -2064,7 +2070,7 @@
           <a:p>
             <a:fld id="{9021E875-82EE-4D84-97F4-14491609B700}" type="datetimeFigureOut">
               <a:rPr lang="ko-KR" altLang="en-US" smtClean="0"/>
-              <a:t>2026-03-23</a:t>
+              <a:t>2026-03-26</a:t>
             </a:fld>
             <a:endParaRPr lang="ko-KR" altLang="en-US"/>
           </a:p>
@@ -2375,7 +2381,7 @@
           <a:p>
             <a:fld id="{9021E875-82EE-4D84-97F4-14491609B700}" type="datetimeFigureOut">
               <a:rPr lang="ko-KR" altLang="en-US" smtClean="0"/>
-              <a:t>2026-03-23</a:t>
+              <a:t>2026-03-26</a:t>
             </a:fld>
             <a:endParaRPr lang="ko-KR" altLang="en-US"/>
           </a:p>
@@ -2663,7 +2669,7 @@
           <a:p>
             <a:fld id="{9021E875-82EE-4D84-97F4-14491609B700}" type="datetimeFigureOut">
               <a:rPr lang="ko-KR" altLang="en-US" smtClean="0"/>
-              <a:t>2026-03-23</a:t>
+              <a:t>2026-03-26</a:t>
             </a:fld>
             <a:endParaRPr lang="ko-KR" altLang="en-US"/>
           </a:p>
@@ -2904,7 +2910,7 @@
           <a:p>
             <a:fld id="{9021E875-82EE-4D84-97F4-14491609B700}" type="datetimeFigureOut">
               <a:rPr lang="ko-KR" altLang="en-US" smtClean="0"/>
-              <a:t>2026-03-23</a:t>
+              <a:t>2026-03-26</a:t>
             </a:fld>
             <a:endParaRPr lang="ko-KR" altLang="en-US"/>
           </a:p>
@@ -3344,7 +3350,7 @@
         </p:blipFill>
         <p:spPr>
           <a:xfrm>
-            <a:off x="130003" y="147782"/>
+            <a:off x="337821" y="1893455"/>
             <a:ext cx="3537527" cy="2676899"/>
           </a:xfrm>
           <a:prstGeom prst="rect">
@@ -3374,7 +3380,7 @@
         </p:blipFill>
         <p:spPr>
           <a:xfrm>
-            <a:off x="4563883" y="147782"/>
+            <a:off x="4771701" y="1893455"/>
             <a:ext cx="3959303" cy="2682571"/>
           </a:xfrm>
           <a:prstGeom prst="rect">
@@ -3396,7 +3402,7 @@
         </p:nvSpPr>
         <p:spPr>
           <a:xfrm rot="20075598">
-            <a:off x="3687862" y="1343069"/>
+            <a:off x="3895680" y="3088742"/>
             <a:ext cx="849746" cy="286327"/>
           </a:xfrm>
           <a:prstGeom prst="rightArrow">
@@ -3450,7 +3456,7 @@
         </p:blipFill>
         <p:spPr>
           <a:xfrm>
-            <a:off x="9189077" y="146044"/>
+            <a:off x="9396895" y="1891717"/>
             <a:ext cx="2019582" cy="3924848"/>
           </a:xfrm>
           <a:prstGeom prst="rect">
@@ -3472,7 +3478,7 @@
         </p:nvSpPr>
         <p:spPr>
           <a:xfrm>
-            <a:off x="4557940" y="2824681"/>
+            <a:off x="4765758" y="4570354"/>
             <a:ext cx="3740727" cy="646331"/>
           </a:xfrm>
           <a:prstGeom prst="rect">
@@ -3486,6 +3492,7 @@
           </a:bodyPr>
           <a:lstStyle/>
           <a:p>
+            <a:pPr algn="ctr"/>
             <a:r>
               <a:rPr lang="ko-KR" altLang="en-US" sz="1200" dirty="0"/>
               <a:t>독 이름에 </a:t>
@@ -3521,6 +3528,7 @@
             <a:endParaRPr lang="en-US" altLang="ko-KR" sz="1200" dirty="0"/>
           </a:p>
           <a:p>
+            <a:pPr algn="ctr"/>
             <a:r>
               <a:rPr lang="en-US" altLang="ko-KR" sz="1200" dirty="0"/>
               <a:t>URL</a:t>
@@ -3548,6 +3556,7 @@
             <a:endParaRPr lang="en-US" altLang="ko-KR" sz="1200" dirty="0"/>
           </a:p>
           <a:p>
+            <a:pPr algn="ctr"/>
             <a:r>
               <a:rPr lang="ko-KR" altLang="en-US" sz="1200" dirty="0"/>
               <a:t>적용 클릭</a:t>
@@ -3569,7 +3578,7 @@
         </p:nvSpPr>
         <p:spPr>
           <a:xfrm>
-            <a:off x="130003" y="2824681"/>
+            <a:off x="337821" y="4570354"/>
             <a:ext cx="3537527" cy="276999"/>
           </a:xfrm>
           <a:prstGeom prst="rect">
@@ -3621,7 +3630,7 @@
         </p:nvSpPr>
         <p:spPr>
           <a:xfrm>
-            <a:off x="9189078" y="4070892"/>
+            <a:off x="9396896" y="5816565"/>
             <a:ext cx="2019582" cy="276999"/>
           </a:xfrm>
           <a:prstGeom prst="rect">
@@ -3643,324 +3652,26 @@
           </a:p>
         </p:txBody>
       </p:sp>
-      <p:grpSp>
-        <p:nvGrpSpPr>
-          <p:cNvPr id="24" name="그룹 23">
-            <a:extLst>
-              <a:ext uri="{FF2B5EF4-FFF2-40B4-BE49-F238E27FC236}">
-                <a16:creationId xmlns:a16="http://schemas.microsoft.com/office/drawing/2014/main" id="{661C21B2-237C-CDC8-BFA6-89C08552240E}"/>
-              </a:ext>
-            </a:extLst>
-          </p:cNvPr>
-          <p:cNvGrpSpPr/>
+      <p:sp>
+        <p:nvSpPr>
+          <p:cNvPr id="31" name="타원 30">
+            <a:extLst>
+              <a:ext uri="{FF2B5EF4-FFF2-40B4-BE49-F238E27FC236}">
+                <a16:creationId xmlns:a16="http://schemas.microsoft.com/office/drawing/2014/main" id="{476384B1-15B4-B00D-E382-FAC2A723E15B}"/>
+              </a:ext>
+            </a:extLst>
+          </p:cNvPr>
+          <p:cNvSpPr/>
           <p:nvPr/>
-        </p:nvGrpSpPr>
-        <p:grpSpPr>
-          <a:xfrm>
-            <a:off x="130003" y="3923502"/>
-            <a:ext cx="5623096" cy="2695698"/>
-            <a:chOff x="130002" y="3646503"/>
-            <a:chExt cx="6153622" cy="2950031"/>
-          </a:xfrm>
-        </p:grpSpPr>
-        <p:pic>
-          <p:nvPicPr>
-            <p:cNvPr id="15" name="그림 14">
-              <a:extLst>
-                <a:ext uri="{FF2B5EF4-FFF2-40B4-BE49-F238E27FC236}">
-                  <a16:creationId xmlns:a16="http://schemas.microsoft.com/office/drawing/2014/main" id="{5641C4F2-3E80-ADC9-C8E7-09DB49F05D32}"/>
-                </a:ext>
-              </a:extLst>
-            </p:cNvPr>
-            <p:cNvPicPr>
-              <a:picLocks noChangeAspect="1"/>
-            </p:cNvPicPr>
-            <p:nvPr/>
-          </p:nvPicPr>
-          <p:blipFill>
-            <a:blip r:embed="rId5"/>
-            <a:stretch>
-              <a:fillRect/>
-            </a:stretch>
-          </p:blipFill>
-          <p:spPr>
-            <a:xfrm>
-              <a:off x="130003" y="3646503"/>
-              <a:ext cx="2711108" cy="2646898"/>
-            </a:xfrm>
-            <a:prstGeom prst="rect">
-              <a:avLst/>
-            </a:prstGeom>
-          </p:spPr>
-        </p:pic>
-        <p:pic>
-          <p:nvPicPr>
-            <p:cNvPr id="17" name="그림 16">
-              <a:extLst>
-                <a:ext uri="{FF2B5EF4-FFF2-40B4-BE49-F238E27FC236}">
-                  <a16:creationId xmlns:a16="http://schemas.microsoft.com/office/drawing/2014/main" id="{1496394D-CB59-A3A2-FD3A-73846D8C666E}"/>
-                </a:ext>
-              </a:extLst>
-            </p:cNvPr>
-            <p:cNvPicPr>
-              <a:picLocks noChangeAspect="1"/>
-            </p:cNvPicPr>
-            <p:nvPr/>
-          </p:nvPicPr>
-          <p:blipFill>
-            <a:blip r:embed="rId6"/>
-            <a:srcRect b="1330"/>
-            <a:stretch>
-              <a:fillRect/>
-            </a:stretch>
-          </p:blipFill>
-          <p:spPr>
-            <a:xfrm>
-              <a:off x="3348286" y="3646504"/>
-              <a:ext cx="2632630" cy="2646898"/>
-            </a:xfrm>
-            <a:prstGeom prst="rect">
-              <a:avLst/>
-            </a:prstGeom>
-          </p:spPr>
-        </p:pic>
-        <p:sp>
-          <p:nvSpPr>
-            <p:cNvPr id="19" name="TextBox 18">
-              <a:extLst>
-                <a:ext uri="{FF2B5EF4-FFF2-40B4-BE49-F238E27FC236}">
-                  <a16:creationId xmlns:a16="http://schemas.microsoft.com/office/drawing/2014/main" id="{7E01D04B-BE3D-3525-1AD6-78CF625C7BB0}"/>
-                </a:ext>
-              </a:extLst>
-            </p:cNvPr>
-            <p:cNvSpPr txBox="1"/>
-            <p:nvPr/>
-          </p:nvSpPr>
-          <p:spPr>
-            <a:xfrm>
-              <a:off x="130002" y="6293401"/>
-              <a:ext cx="2711107" cy="276999"/>
-            </a:xfrm>
-            <a:prstGeom prst="rect">
-              <a:avLst/>
-            </a:prstGeom>
-            <a:noFill/>
-          </p:spPr>
-          <p:txBody>
-            <a:bodyPr wrap="square">
-              <a:spAutoFit/>
-            </a:bodyPr>
-            <a:lstStyle/>
-            <a:p>
-              <a:pPr algn="ctr"/>
-              <a:r>
-                <a:rPr lang="ko-KR" altLang="en-US" sz="1200"/>
-                <a:t>설정 열기 클릭</a:t>
-              </a:r>
-              <a:endParaRPr lang="ko-KR" altLang="en-US" sz="1200" dirty="0"/>
-            </a:p>
-          </p:txBody>
-        </p:sp>
-        <p:sp>
-          <p:nvSpPr>
-            <p:cNvPr id="20" name="사각형: 둥근 모서리 19">
-              <a:extLst>
-                <a:ext uri="{FF2B5EF4-FFF2-40B4-BE49-F238E27FC236}">
-                  <a16:creationId xmlns:a16="http://schemas.microsoft.com/office/drawing/2014/main" id="{A6D044ED-785F-3F11-490B-AC54EDEB9B3D}"/>
-                </a:ext>
-              </a:extLst>
-            </p:cNvPr>
-            <p:cNvSpPr/>
-            <p:nvPr/>
-          </p:nvSpPr>
-          <p:spPr>
-            <a:xfrm>
-              <a:off x="130002" y="5209309"/>
-              <a:ext cx="2622435" cy="406400"/>
-            </a:xfrm>
-            <a:prstGeom prst="roundRect">
-              <a:avLst/>
-            </a:prstGeom>
-            <a:noFill/>
-            <a:ln w="28575">
-              <a:solidFill>
-                <a:srgbClr val="FF0000"/>
-              </a:solidFill>
-              <a:prstDash val="dash"/>
-            </a:ln>
-          </p:spPr>
-          <p:style>
-            <a:lnRef idx="2">
-              <a:schemeClr val="accent1">
-                <a:shade val="15000"/>
-              </a:schemeClr>
-            </a:lnRef>
-            <a:fillRef idx="1">
-              <a:schemeClr val="accent1"/>
-            </a:fillRef>
-            <a:effectRef idx="0">
-              <a:schemeClr val="accent1"/>
-            </a:effectRef>
-            <a:fontRef idx="minor">
-              <a:schemeClr val="lt1"/>
-            </a:fontRef>
-          </p:style>
-          <p:txBody>
-            <a:bodyPr rtlCol="0" anchor="ctr"/>
-            <a:lstStyle/>
-            <a:p>
-              <a:pPr algn="ctr"/>
-              <a:endParaRPr lang="ko-KR" altLang="en-US"/>
-            </a:p>
-          </p:txBody>
-        </p:sp>
-        <p:sp>
-          <p:nvSpPr>
-            <p:cNvPr id="21" name="사각형: 둥근 모서리 20">
-              <a:extLst>
-                <a:ext uri="{FF2B5EF4-FFF2-40B4-BE49-F238E27FC236}">
-                  <a16:creationId xmlns:a16="http://schemas.microsoft.com/office/drawing/2014/main" id="{92694B41-B449-A5C0-2EDF-7CFE26BBABA4}"/>
-                </a:ext>
-              </a:extLst>
-            </p:cNvPr>
-            <p:cNvSpPr/>
-            <p:nvPr/>
-          </p:nvSpPr>
-          <p:spPr>
-            <a:xfrm>
-              <a:off x="3538222" y="5809673"/>
-              <a:ext cx="2271452" cy="406400"/>
-            </a:xfrm>
-            <a:prstGeom prst="roundRect">
-              <a:avLst/>
-            </a:prstGeom>
-            <a:noFill/>
-            <a:ln w="28575">
-              <a:solidFill>
-                <a:srgbClr val="FF0000"/>
-              </a:solidFill>
-              <a:prstDash val="dash"/>
-            </a:ln>
-          </p:spPr>
-          <p:style>
-            <a:lnRef idx="2">
-              <a:schemeClr val="accent1">
-                <a:shade val="15000"/>
-              </a:schemeClr>
-            </a:lnRef>
-            <a:fillRef idx="1">
-              <a:schemeClr val="accent1"/>
-            </a:fillRef>
-            <a:effectRef idx="0">
-              <a:schemeClr val="accent1"/>
-            </a:effectRef>
-            <a:fontRef idx="minor">
-              <a:schemeClr val="lt1"/>
-            </a:fontRef>
-          </p:style>
-          <p:txBody>
-            <a:bodyPr rtlCol="0" anchor="ctr"/>
-            <a:lstStyle/>
-            <a:p>
-              <a:pPr algn="ctr"/>
-              <a:endParaRPr lang="ko-KR" altLang="en-US"/>
-            </a:p>
-          </p:txBody>
-        </p:sp>
-        <p:sp>
-          <p:nvSpPr>
-            <p:cNvPr id="22" name="TextBox 21">
-              <a:extLst>
-                <a:ext uri="{FF2B5EF4-FFF2-40B4-BE49-F238E27FC236}">
-                  <a16:creationId xmlns:a16="http://schemas.microsoft.com/office/drawing/2014/main" id="{5E8BB717-1171-7F2B-543A-406666C33081}"/>
-                </a:ext>
-              </a:extLst>
-            </p:cNvPr>
-            <p:cNvSpPr txBox="1"/>
-            <p:nvPr/>
-          </p:nvSpPr>
-          <p:spPr>
-            <a:xfrm>
-              <a:off x="3045579" y="6293401"/>
-              <a:ext cx="3238045" cy="303133"/>
-            </a:xfrm>
-            <a:prstGeom prst="rect">
-              <a:avLst/>
-            </a:prstGeom>
-            <a:noFill/>
-          </p:spPr>
-          <p:txBody>
-            <a:bodyPr wrap="square">
-              <a:spAutoFit/>
-            </a:bodyPr>
-            <a:lstStyle/>
-            <a:p>
-              <a:pPr algn="ctr"/>
-              <a:r>
-                <a:rPr lang="ko-KR" altLang="en-US" sz="1200" dirty="0"/>
-                <a:t>아래 칸에 본인 방송 주소 넣고 저장</a:t>
-              </a:r>
-            </a:p>
-          </p:txBody>
-        </p:sp>
-      </p:grpSp>
-      <p:pic>
-        <p:nvPicPr>
-          <p:cNvPr id="26" name="그림 25">
-            <a:extLst>
-              <a:ext uri="{FF2B5EF4-FFF2-40B4-BE49-F238E27FC236}">
-                <a16:creationId xmlns:a16="http://schemas.microsoft.com/office/drawing/2014/main" id="{F9A1B060-25C1-9442-6936-25C684CAE36F}"/>
-              </a:ext>
-            </a:extLst>
-          </p:cNvPr>
-          <p:cNvPicPr>
-            <a:picLocks noChangeAspect="1"/>
-          </p:cNvPicPr>
-          <p:nvPr/>
-        </p:nvPicPr>
-        <p:blipFill>
-          <a:blip r:embed="rId7"/>
-          <a:stretch>
-            <a:fillRect/>
-          </a:stretch>
-        </p:blipFill>
-        <p:spPr>
-          <a:xfrm>
-            <a:off x="6096000" y="4639154"/>
-            <a:ext cx="2857503" cy="1424837"/>
-          </a:xfrm>
-          <a:prstGeom prst="rect">
+        </p:nvSpPr>
+        <p:spPr>
+          <a:xfrm>
+            <a:off x="190385" y="1742059"/>
+            <a:ext cx="294870" cy="294870"/>
+          </a:xfrm>
+          <a:prstGeom prst="ellipse">
             <a:avLst/>
           </a:prstGeom>
-        </p:spPr>
-      </p:pic>
-      <p:sp>
-        <p:nvSpPr>
-          <p:cNvPr id="27" name="사각형: 둥근 모서리 26">
-            <a:extLst>
-              <a:ext uri="{FF2B5EF4-FFF2-40B4-BE49-F238E27FC236}">
-                <a16:creationId xmlns:a16="http://schemas.microsoft.com/office/drawing/2014/main" id="{165DA55D-D1B9-95F4-EDCF-D88A3613FF18}"/>
-              </a:ext>
-            </a:extLst>
-          </p:cNvPr>
-          <p:cNvSpPr/>
-          <p:nvPr/>
-        </p:nvSpPr>
-        <p:spPr>
-          <a:xfrm>
-            <a:off x="6096000" y="4633482"/>
-            <a:ext cx="1485900" cy="718091"/>
-          </a:xfrm>
-          <a:prstGeom prst="roundRect">
-            <a:avLst/>
-          </a:prstGeom>
-          <a:noFill/>
-          <a:ln w="28575">
-            <a:solidFill>
-              <a:srgbClr val="FF0000"/>
-            </a:solidFill>
-            <a:prstDash val="dash"/>
-          </a:ln>
         </p:spPr>
         <p:style>
           <a:lnRef idx="2">
@@ -3983,114 +3694,20 @@
           <a:lstStyle/>
           <a:p>
             <a:pPr algn="ctr"/>
-            <a:endParaRPr lang="ko-KR" altLang="en-US"/>
-          </a:p>
-        </p:txBody>
-      </p:sp>
-      <p:sp>
-        <p:nvSpPr>
-          <p:cNvPr id="29" name="TextBox 28">
-            <a:extLst>
-              <a:ext uri="{FF2B5EF4-FFF2-40B4-BE49-F238E27FC236}">
-                <a16:creationId xmlns:a16="http://schemas.microsoft.com/office/drawing/2014/main" id="{9885E811-FAF6-E41F-5811-86744CAFCDD6}"/>
-              </a:ext>
-            </a:extLst>
-          </p:cNvPr>
-          <p:cNvSpPr txBox="1"/>
-          <p:nvPr/>
-        </p:nvSpPr>
-        <p:spPr>
-          <a:xfrm>
-            <a:off x="6096000" y="6085858"/>
-            <a:ext cx="2857503" cy="276999"/>
-          </a:xfrm>
-          <a:prstGeom prst="rect">
-            <a:avLst/>
-          </a:prstGeom>
-          <a:noFill/>
-        </p:spPr>
-        <p:txBody>
-          <a:bodyPr wrap="square">
-            <a:spAutoFit/>
-          </a:bodyPr>
-          <a:lstStyle/>
-          <a:p>
-            <a:pPr algn="ctr"/>
-            <a:r>
-              <a:rPr lang="ko-KR" altLang="en-US" sz="1200"/>
-              <a:t>클릭 시 가리고 킬 수 있음</a:t>
-            </a:r>
-            <a:endParaRPr lang="ko-KR" altLang="en-US" sz="1200" dirty="0"/>
-          </a:p>
-        </p:txBody>
-      </p:sp>
-      <p:sp>
-        <p:nvSpPr>
-          <p:cNvPr id="30" name="TextBox 29">
-            <a:extLst>
-              <a:ext uri="{FF2B5EF4-FFF2-40B4-BE49-F238E27FC236}">
-                <a16:creationId xmlns:a16="http://schemas.microsoft.com/office/drawing/2014/main" id="{DBC98B5E-F2CF-0351-2B22-9D04D781141C}"/>
-              </a:ext>
-            </a:extLst>
-          </p:cNvPr>
-          <p:cNvSpPr txBox="1"/>
-          <p:nvPr/>
-        </p:nvSpPr>
-        <p:spPr>
-          <a:xfrm>
-            <a:off x="8953503" y="6388367"/>
-            <a:ext cx="3238497" cy="461665"/>
-          </a:xfrm>
-          <a:prstGeom prst="rect">
-            <a:avLst/>
-          </a:prstGeom>
-          <a:noFill/>
-        </p:spPr>
-        <p:txBody>
-          <a:bodyPr wrap="square">
-            <a:spAutoFit/>
-          </a:bodyPr>
-          <a:lstStyle/>
-          <a:p>
-            <a:pPr algn="r"/>
-            <a:r>
-              <a:rPr lang="en-US" altLang="ko-KR" sz="1200" dirty="0"/>
-              <a:t>*</a:t>
-            </a:r>
-            <a:r>
-              <a:rPr lang="ko-KR" altLang="en-US" sz="1200" dirty="0"/>
-              <a:t>추후 방제</a:t>
-            </a:r>
-            <a:r>
-              <a:rPr lang="en-US" altLang="ko-KR" sz="1200" dirty="0"/>
-              <a:t>, </a:t>
-            </a:r>
-            <a:r>
-              <a:rPr lang="ko-KR" altLang="en-US" sz="1200" dirty="0"/>
-              <a:t>카테고리 등 변경기능 추가 예정</a:t>
-            </a:r>
-            <a:r>
-              <a:rPr lang="en-US" altLang="ko-KR" sz="1200" dirty="0"/>
-              <a:t>(</a:t>
-            </a:r>
-            <a:r>
-              <a:rPr lang="ko-KR" altLang="en-US" sz="1200" dirty="0"/>
-              <a:t>이지만 안될 수도</a:t>
-            </a:r>
-            <a:r>
-              <a:rPr lang="en-US" altLang="ko-KR" sz="1200" dirty="0"/>
-              <a:t>…!)</a:t>
-            </a:r>
-            <a:endParaRPr lang="ko-KR" altLang="en-US" sz="1200" dirty="0"/>
-          </a:p>
-        </p:txBody>
-      </p:sp>
-      <p:sp>
-        <p:nvSpPr>
-          <p:cNvPr id="31" name="타원 30">
-            <a:extLst>
-              <a:ext uri="{FF2B5EF4-FFF2-40B4-BE49-F238E27FC236}">
-                <a16:creationId xmlns:a16="http://schemas.microsoft.com/office/drawing/2014/main" id="{476384B1-15B4-B00D-E382-FAC2A723E15B}"/>
+            <a:r>
+              <a:rPr lang="en-US" altLang="ko-KR" dirty="0"/>
+              <a:t>1</a:t>
+            </a:r>
+            <a:endParaRPr lang="ko-KR" altLang="en-US" dirty="0"/>
+          </a:p>
+        </p:txBody>
+      </p:sp>
+      <p:sp>
+        <p:nvSpPr>
+          <p:cNvPr id="32" name="타원 31">
+            <a:extLst>
+              <a:ext uri="{FF2B5EF4-FFF2-40B4-BE49-F238E27FC236}">
+                <a16:creationId xmlns:a16="http://schemas.microsoft.com/office/drawing/2014/main" id="{F0A49D40-14D5-9ECC-40FF-D3983F6F20F1}"/>
               </a:ext>
             </a:extLst>
           </p:cNvPr>
@@ -4099,7 +3716,7 @@
         </p:nvSpPr>
         <p:spPr>
           <a:xfrm>
-            <a:off x="-17433" y="-3614"/>
+            <a:off x="4646205" y="1742059"/>
             <a:ext cx="294870" cy="294870"/>
           </a:xfrm>
           <a:prstGeom prst="ellipse">
@@ -4129,7 +3746,7 @@
             <a:pPr algn="ctr"/>
             <a:r>
               <a:rPr lang="en-US" altLang="ko-KR" dirty="0"/>
-              <a:t>1</a:t>
+              <a:t>2</a:t>
             </a:r>
             <a:endParaRPr lang="ko-KR" altLang="en-US" dirty="0"/>
           </a:p>
@@ -4137,10 +3754,10 @@
       </p:sp>
       <p:sp>
         <p:nvSpPr>
-          <p:cNvPr id="32" name="타원 31">
-            <a:extLst>
-              <a:ext uri="{FF2B5EF4-FFF2-40B4-BE49-F238E27FC236}">
-                <a16:creationId xmlns:a16="http://schemas.microsoft.com/office/drawing/2014/main" id="{F0A49D40-14D5-9ECC-40FF-D3983F6F20F1}"/>
+          <p:cNvPr id="33" name="타원 32">
+            <a:extLst>
+              <a:ext uri="{FF2B5EF4-FFF2-40B4-BE49-F238E27FC236}">
+                <a16:creationId xmlns:a16="http://schemas.microsoft.com/office/drawing/2014/main" id="{2854C480-14A9-02C3-0CCC-14BCD51461B3}"/>
               </a:ext>
             </a:extLst>
           </p:cNvPr>
@@ -4149,7 +3766,7 @@
         </p:nvSpPr>
         <p:spPr>
           <a:xfrm>
-            <a:off x="4438387" y="-3614"/>
+            <a:off x="9249459" y="1742059"/>
             <a:ext cx="294870" cy="294870"/>
           </a:xfrm>
           <a:prstGeom prst="ellipse">
@@ -4179,7 +3796,7 @@
             <a:pPr algn="ctr"/>
             <a:r>
               <a:rPr lang="en-US" altLang="ko-KR" dirty="0"/>
-              <a:t>2</a:t>
+              <a:t>3</a:t>
             </a:r>
             <a:endParaRPr lang="ko-KR" altLang="en-US" dirty="0"/>
           </a:p>
@@ -4187,10 +3804,49 @@
       </p:sp>
       <p:sp>
         <p:nvSpPr>
-          <p:cNvPr id="33" name="타원 32">
-            <a:extLst>
-              <a:ext uri="{FF2B5EF4-FFF2-40B4-BE49-F238E27FC236}">
-                <a16:creationId xmlns:a16="http://schemas.microsoft.com/office/drawing/2014/main" id="{2854C480-14A9-02C3-0CCC-14BCD51461B3}"/>
+          <p:cNvPr id="9" name="TextBox 8">
+            <a:extLst>
+              <a:ext uri="{FF2B5EF4-FFF2-40B4-BE49-F238E27FC236}">
+                <a16:creationId xmlns:a16="http://schemas.microsoft.com/office/drawing/2014/main" id="{45192AC7-E3F3-FB3F-D9C6-59147F8BEA2C}"/>
+              </a:ext>
+            </a:extLst>
+          </p:cNvPr>
+          <p:cNvSpPr txBox="1"/>
+          <p:nvPr/>
+        </p:nvSpPr>
+        <p:spPr>
+          <a:xfrm>
+            <a:off x="190385" y="216220"/>
+            <a:ext cx="2662908" cy="523220"/>
+          </a:xfrm>
+          <a:prstGeom prst="rect">
+            <a:avLst/>
+          </a:prstGeom>
+          <a:noFill/>
+        </p:spPr>
+        <p:txBody>
+          <a:bodyPr wrap="none" rtlCol="0">
+            <a:spAutoFit/>
+          </a:bodyPr>
+          <a:lstStyle/>
+          <a:p>
+            <a:r>
+              <a:rPr lang="en-US" altLang="ko-KR" sz="2800" b="1" dirty="0"/>
+              <a:t>1. </a:t>
+            </a:r>
+            <a:r>
+              <a:rPr lang="ko-KR" altLang="en-US" sz="2800" b="1" dirty="0"/>
+              <a:t>독 추가 방법</a:t>
+            </a:r>
+          </a:p>
+        </p:txBody>
+      </p:sp>
+      <p:sp>
+        <p:nvSpPr>
+          <p:cNvPr id="11" name="사각형: 둥근 모서리 10">
+            <a:extLst>
+              <a:ext uri="{FF2B5EF4-FFF2-40B4-BE49-F238E27FC236}">
+                <a16:creationId xmlns:a16="http://schemas.microsoft.com/office/drawing/2014/main" id="{EE0E9D9F-6775-0115-E39F-8C115ACCA340}"/>
               </a:ext>
             </a:extLst>
           </p:cNvPr>
@@ -4199,12 +3855,19 @@
         </p:nvSpPr>
         <p:spPr>
           <a:xfrm>
-            <a:off x="9041641" y="-3614"/>
-            <a:ext cx="294870" cy="294870"/>
-          </a:xfrm>
-          <a:prstGeom prst="ellipse">
+            <a:off x="1870363" y="3147742"/>
+            <a:ext cx="2080989" cy="481655"/>
+          </a:xfrm>
+          <a:prstGeom prst="roundRect">
             <a:avLst/>
           </a:prstGeom>
+          <a:noFill/>
+          <a:ln w="28575">
+            <a:solidFill>
+              <a:srgbClr val="FF0000"/>
+            </a:solidFill>
+            <a:prstDash val="dash"/>
+          </a:ln>
         </p:spPr>
         <p:style>
           <a:lnRef idx="2">
@@ -4227,20 +3890,16 @@
           <a:lstStyle/>
           <a:p>
             <a:pPr algn="ctr"/>
-            <a:r>
-              <a:rPr lang="en-US" altLang="ko-KR" dirty="0"/>
-              <a:t>3</a:t>
-            </a:r>
-            <a:endParaRPr lang="ko-KR" altLang="en-US" dirty="0"/>
-          </a:p>
-        </p:txBody>
-      </p:sp>
-      <p:sp>
-        <p:nvSpPr>
-          <p:cNvPr id="34" name="타원 33">
-            <a:extLst>
-              <a:ext uri="{FF2B5EF4-FFF2-40B4-BE49-F238E27FC236}">
-                <a16:creationId xmlns:a16="http://schemas.microsoft.com/office/drawing/2014/main" id="{100B32B0-157F-F1F8-E1C8-80EAD3A35172}"/>
+            <a:endParaRPr lang="ko-KR" altLang="en-US"/>
+          </a:p>
+        </p:txBody>
+      </p:sp>
+      <p:sp>
+        <p:nvSpPr>
+          <p:cNvPr id="14" name="사각형: 둥근 모서리 13">
+            <a:extLst>
+              <a:ext uri="{FF2B5EF4-FFF2-40B4-BE49-F238E27FC236}">
+                <a16:creationId xmlns:a16="http://schemas.microsoft.com/office/drawing/2014/main" id="{BA52DA41-DBFE-42C8-EA4C-A1183775C21E}"/>
               </a:ext>
             </a:extLst>
           </p:cNvPr>
@@ -4249,12 +3908,19 @@
         </p:nvSpPr>
         <p:spPr>
           <a:xfrm>
-            <a:off x="0" y="3756321"/>
-            <a:ext cx="294870" cy="294870"/>
-          </a:xfrm>
-          <a:prstGeom prst="ellipse">
+            <a:off x="1870363" y="2036930"/>
+            <a:ext cx="592284" cy="415325"/>
+          </a:xfrm>
+          <a:prstGeom prst="roundRect">
             <a:avLst/>
           </a:prstGeom>
+          <a:noFill/>
+          <a:ln w="28575">
+            <a:solidFill>
+              <a:srgbClr val="FF0000"/>
+            </a:solidFill>
+            <a:prstDash val="dash"/>
+          </a:ln>
         </p:spPr>
         <p:style>
           <a:lnRef idx="2">
@@ -4277,20 +3943,16 @@
           <a:lstStyle/>
           <a:p>
             <a:pPr algn="ctr"/>
-            <a:r>
-              <a:rPr lang="en-US" altLang="ko-KR" dirty="0"/>
-              <a:t>4</a:t>
-            </a:r>
-            <a:endParaRPr lang="ko-KR" altLang="en-US" dirty="0"/>
-          </a:p>
-        </p:txBody>
-      </p:sp>
-      <p:sp>
-        <p:nvSpPr>
-          <p:cNvPr id="35" name="타원 34">
-            <a:extLst>
-              <a:ext uri="{FF2B5EF4-FFF2-40B4-BE49-F238E27FC236}">
-                <a16:creationId xmlns:a16="http://schemas.microsoft.com/office/drawing/2014/main" id="{D307EDD9-F0EF-E731-9200-B043E5B99588}"/>
+            <a:endParaRPr lang="ko-KR" altLang="en-US"/>
+          </a:p>
+        </p:txBody>
+      </p:sp>
+      <p:sp>
+        <p:nvSpPr>
+          <p:cNvPr id="25" name="사각형: 둥근 모서리 24">
+            <a:extLst>
+              <a:ext uri="{FF2B5EF4-FFF2-40B4-BE49-F238E27FC236}">
+                <a16:creationId xmlns:a16="http://schemas.microsoft.com/office/drawing/2014/main" id="{F04081AB-E46D-AE36-4138-A4D5A6E4A114}"/>
               </a:ext>
             </a:extLst>
           </p:cNvPr>
@@ -4299,12 +3961,19 @@
         </p:nvSpPr>
         <p:spPr>
           <a:xfrm>
-            <a:off x="2949518" y="3756321"/>
-            <a:ext cx="294870" cy="294870"/>
-          </a:xfrm>
-          <a:prstGeom prst="ellipse">
+            <a:off x="4716480" y="2879959"/>
+            <a:ext cx="4014524" cy="247002"/>
+          </a:xfrm>
+          <a:prstGeom prst="roundRect">
             <a:avLst/>
           </a:prstGeom>
+          <a:noFill/>
+          <a:ln w="28575">
+            <a:solidFill>
+              <a:srgbClr val="FF0000"/>
+            </a:solidFill>
+            <a:prstDash val="dash"/>
+          </a:ln>
         </p:spPr>
         <p:style>
           <a:lnRef idx="2">
@@ -4327,20 +3996,16 @@
           <a:lstStyle/>
           <a:p>
             <a:pPr algn="ctr"/>
-            <a:r>
-              <a:rPr lang="en-US" altLang="ko-KR" dirty="0"/>
-              <a:t>5</a:t>
-            </a:r>
-            <a:endParaRPr lang="ko-KR" altLang="en-US" dirty="0"/>
-          </a:p>
-        </p:txBody>
-      </p:sp>
-      <p:sp>
-        <p:nvSpPr>
-          <p:cNvPr id="36" name="타원 35">
-            <a:extLst>
-              <a:ext uri="{FF2B5EF4-FFF2-40B4-BE49-F238E27FC236}">
-                <a16:creationId xmlns:a16="http://schemas.microsoft.com/office/drawing/2014/main" id="{150F11CA-0381-E2D9-FFCC-E6394C5A700D}"/>
+            <a:endParaRPr lang="ko-KR" altLang="en-US"/>
+          </a:p>
+        </p:txBody>
+      </p:sp>
+      <p:sp>
+        <p:nvSpPr>
+          <p:cNvPr id="28" name="사각형: 둥근 모서리 27">
+            <a:extLst>
+              <a:ext uri="{FF2B5EF4-FFF2-40B4-BE49-F238E27FC236}">
+                <a16:creationId xmlns:a16="http://schemas.microsoft.com/office/drawing/2014/main" id="{8E0A196A-1A80-575F-DB45-C5CF2CF5C8AE}"/>
               </a:ext>
             </a:extLst>
           </p:cNvPr>
@@ -4349,12 +4014,19 @@
         </p:nvSpPr>
         <p:spPr>
           <a:xfrm>
-            <a:off x="6014854" y="4370412"/>
-            <a:ext cx="294870" cy="294870"/>
-          </a:xfrm>
-          <a:prstGeom prst="ellipse">
+            <a:off x="9396894" y="5371960"/>
+            <a:ext cx="1987386" cy="381140"/>
+          </a:xfrm>
+          <a:prstGeom prst="roundRect">
             <a:avLst/>
           </a:prstGeom>
+          <a:noFill/>
+          <a:ln w="28575">
+            <a:solidFill>
+              <a:srgbClr val="FF0000"/>
+            </a:solidFill>
+            <a:prstDash val="dash"/>
+          </a:ln>
         </p:spPr>
         <p:style>
           <a:lnRef idx="2">
@@ -4377,11 +4049,7 @@
           <a:lstStyle/>
           <a:p>
             <a:pPr algn="ctr"/>
-            <a:r>
-              <a:rPr lang="en-US" altLang="ko-KR" dirty="0"/>
-              <a:t>6</a:t>
-            </a:r>
-            <a:endParaRPr lang="ko-KR" altLang="en-US" dirty="0"/>
+            <a:endParaRPr lang="ko-KR" altLang="en-US"/>
           </a:p>
         </p:txBody>
       </p:sp>
@@ -4389,6 +4057,960 @@
     <p:extLst>
       <p:ext uri="{BB962C8B-B14F-4D97-AF65-F5344CB8AC3E}">
         <p14:creationId xmlns:p14="http://schemas.microsoft.com/office/powerpoint/2010/main" val="2991111512"/>
+      </p:ext>
+    </p:extLst>
+  </p:cSld>
+  <p:clrMapOvr>
+    <a:masterClrMapping/>
+  </p:clrMapOvr>
+</p:sld>
+</file>
+
+<file path=ppt/slides/slide2.xml><?xml version="1.0" encoding="utf-8"?>
+<p:sld xmlns:a="http://schemas.openxmlformats.org/drawingml/2006/main" xmlns:r="http://schemas.openxmlformats.org/officeDocument/2006/relationships" xmlns:p="http://schemas.openxmlformats.org/presentationml/2006/main">
+  <p:cSld>
+    <p:spTree>
+      <p:nvGrpSpPr>
+        <p:cNvPr id="1" name="">
+          <a:extLst>
+            <a:ext uri="{FF2B5EF4-FFF2-40B4-BE49-F238E27FC236}">
+              <a16:creationId xmlns:a16="http://schemas.microsoft.com/office/drawing/2014/main" id="{9BC90B98-55F8-F74A-4CDC-71A8BCB9D4CF}"/>
+            </a:ext>
+          </a:extLst>
+        </p:cNvPr>
+        <p:cNvGrpSpPr/>
+        <p:nvPr/>
+      </p:nvGrpSpPr>
+      <p:grpSpPr>
+        <a:xfrm>
+          <a:off x="0" y="0"/>
+          <a:ext cx="0" cy="0"/>
+          <a:chOff x="0" y="0"/>
+          <a:chExt cx="0" cy="0"/>
+        </a:xfrm>
+      </p:grpSpPr>
+      <p:pic>
+        <p:nvPicPr>
+          <p:cNvPr id="4" name="그림 3">
+            <a:extLst>
+              <a:ext uri="{FF2B5EF4-FFF2-40B4-BE49-F238E27FC236}">
+                <a16:creationId xmlns:a16="http://schemas.microsoft.com/office/drawing/2014/main" id="{08A12200-8324-D9F4-1F58-31061EE00D44}"/>
+              </a:ext>
+            </a:extLst>
+          </p:cNvPr>
+          <p:cNvPicPr>
+            <a:picLocks noChangeAspect="1"/>
+          </p:cNvPicPr>
+          <p:nvPr/>
+        </p:nvPicPr>
+        <p:blipFill>
+          <a:blip r:embed="rId2"/>
+          <a:stretch>
+            <a:fillRect/>
+          </a:stretch>
+        </p:blipFill>
+        <p:spPr>
+          <a:xfrm>
+            <a:off x="3913338" y="266401"/>
+            <a:ext cx="4591691" cy="6106377"/>
+          </a:xfrm>
+          <a:prstGeom prst="rect">
+            <a:avLst/>
+          </a:prstGeom>
+        </p:spPr>
+      </p:pic>
+      <p:pic>
+        <p:nvPicPr>
+          <p:cNvPr id="3" name="그림 2">
+            <a:extLst>
+              <a:ext uri="{FF2B5EF4-FFF2-40B4-BE49-F238E27FC236}">
+                <a16:creationId xmlns:a16="http://schemas.microsoft.com/office/drawing/2014/main" id="{78C59278-5671-1A4A-99F0-36C6D80805B9}"/>
+              </a:ext>
+            </a:extLst>
+          </p:cNvPr>
+          <p:cNvPicPr>
+            <a:picLocks noChangeAspect="1"/>
+          </p:cNvPicPr>
+          <p:nvPr/>
+        </p:nvPicPr>
+        <p:blipFill>
+          <a:blip r:embed="rId3"/>
+          <a:stretch>
+            <a:fillRect/>
+          </a:stretch>
+        </p:blipFill>
+        <p:spPr>
+          <a:xfrm>
+            <a:off x="213795" y="1010275"/>
+            <a:ext cx="3266270" cy="2113469"/>
+          </a:xfrm>
+          <a:prstGeom prst="rect">
+            <a:avLst/>
+          </a:prstGeom>
+        </p:spPr>
+      </p:pic>
+      <p:pic>
+        <p:nvPicPr>
+          <p:cNvPr id="11" name="그림 10">
+            <a:extLst>
+              <a:ext uri="{FF2B5EF4-FFF2-40B4-BE49-F238E27FC236}">
+                <a16:creationId xmlns:a16="http://schemas.microsoft.com/office/drawing/2014/main" id="{4AE07A83-478A-6072-753A-731BBF83D9B4}"/>
+              </a:ext>
+            </a:extLst>
+          </p:cNvPr>
+          <p:cNvPicPr>
+            <a:picLocks noChangeAspect="1"/>
+          </p:cNvPicPr>
+          <p:nvPr/>
+        </p:nvPicPr>
+        <p:blipFill>
+          <a:blip r:embed="rId4"/>
+          <a:srcRect b="26635"/>
+          <a:stretch>
+            <a:fillRect/>
+          </a:stretch>
+        </p:blipFill>
+        <p:spPr>
+          <a:xfrm>
+            <a:off x="8938302" y="1807881"/>
+            <a:ext cx="3122884" cy="1551453"/>
+          </a:xfrm>
+          <a:prstGeom prst="rect">
+            <a:avLst/>
+          </a:prstGeom>
+        </p:spPr>
+      </p:pic>
+      <p:pic>
+        <p:nvPicPr>
+          <p:cNvPr id="6" name="그림 5">
+            <a:extLst>
+              <a:ext uri="{FF2B5EF4-FFF2-40B4-BE49-F238E27FC236}">
+                <a16:creationId xmlns:a16="http://schemas.microsoft.com/office/drawing/2014/main" id="{41C0D186-D37B-5FBA-DEBC-70A225491ABD}"/>
+              </a:ext>
+            </a:extLst>
+          </p:cNvPr>
+          <p:cNvPicPr>
+            <a:picLocks noChangeAspect="1"/>
+          </p:cNvPicPr>
+          <p:nvPr/>
+        </p:nvPicPr>
+        <p:blipFill>
+          <a:blip r:embed="rId5"/>
+          <a:stretch>
+            <a:fillRect/>
+          </a:stretch>
+        </p:blipFill>
+        <p:spPr>
+          <a:xfrm>
+            <a:off x="488381" y="3877885"/>
+            <a:ext cx="2717099" cy="2302230"/>
+          </a:xfrm>
+          <a:prstGeom prst="rect">
+            <a:avLst/>
+          </a:prstGeom>
+        </p:spPr>
+      </p:pic>
+      <p:sp>
+        <p:nvSpPr>
+          <p:cNvPr id="27" name="사각형: 둥근 모서리 26">
+            <a:extLst>
+              <a:ext uri="{FF2B5EF4-FFF2-40B4-BE49-F238E27FC236}">
+                <a16:creationId xmlns:a16="http://schemas.microsoft.com/office/drawing/2014/main" id="{9A347770-E930-9184-FF06-DDE438B5D5CA}"/>
+              </a:ext>
+            </a:extLst>
+          </p:cNvPr>
+          <p:cNvSpPr/>
+          <p:nvPr/>
+        </p:nvSpPr>
+        <p:spPr>
+          <a:xfrm>
+            <a:off x="408216" y="2451552"/>
+            <a:ext cx="2919682" cy="481655"/>
+          </a:xfrm>
+          <a:prstGeom prst="roundRect">
+            <a:avLst/>
+          </a:prstGeom>
+          <a:noFill/>
+          <a:ln w="28575">
+            <a:solidFill>
+              <a:srgbClr val="FF0000"/>
+            </a:solidFill>
+            <a:prstDash val="dash"/>
+          </a:ln>
+        </p:spPr>
+        <p:style>
+          <a:lnRef idx="2">
+            <a:schemeClr val="accent1">
+              <a:shade val="15000"/>
+            </a:schemeClr>
+          </a:lnRef>
+          <a:fillRef idx="1">
+            <a:schemeClr val="accent1"/>
+          </a:fillRef>
+          <a:effectRef idx="0">
+            <a:schemeClr val="accent1"/>
+          </a:effectRef>
+          <a:fontRef idx="minor">
+            <a:schemeClr val="lt1"/>
+          </a:fontRef>
+        </p:style>
+        <p:txBody>
+          <a:bodyPr rtlCol="0" anchor="ctr"/>
+          <a:lstStyle/>
+          <a:p>
+            <a:pPr algn="ctr"/>
+            <a:endParaRPr lang="ko-KR" altLang="en-US"/>
+          </a:p>
+        </p:txBody>
+      </p:sp>
+      <p:sp>
+        <p:nvSpPr>
+          <p:cNvPr id="29" name="TextBox 28">
+            <a:extLst>
+              <a:ext uri="{FF2B5EF4-FFF2-40B4-BE49-F238E27FC236}">
+                <a16:creationId xmlns:a16="http://schemas.microsoft.com/office/drawing/2014/main" id="{3A7A9109-BB37-67EA-A88C-335D6FC8D5A7}"/>
+              </a:ext>
+            </a:extLst>
+          </p:cNvPr>
+          <p:cNvSpPr txBox="1"/>
+          <p:nvPr/>
+        </p:nvSpPr>
+        <p:spPr>
+          <a:xfrm>
+            <a:off x="418179" y="3132679"/>
+            <a:ext cx="2857503" cy="276999"/>
+          </a:xfrm>
+          <a:prstGeom prst="rect">
+            <a:avLst/>
+          </a:prstGeom>
+          <a:noFill/>
+        </p:spPr>
+        <p:txBody>
+          <a:bodyPr wrap="square">
+            <a:spAutoFit/>
+          </a:bodyPr>
+          <a:lstStyle/>
+          <a:p>
+            <a:pPr algn="ctr"/>
+            <a:r>
+              <a:rPr lang="ko-KR" altLang="en-US" sz="1200" dirty="0"/>
+              <a:t>계정 연동을 위해 네이버 로그인 필요</a:t>
+            </a:r>
+          </a:p>
+        </p:txBody>
+      </p:sp>
+      <p:sp>
+        <p:nvSpPr>
+          <p:cNvPr id="31" name="타원 30">
+            <a:extLst>
+              <a:ext uri="{FF2B5EF4-FFF2-40B4-BE49-F238E27FC236}">
+                <a16:creationId xmlns:a16="http://schemas.microsoft.com/office/drawing/2014/main" id="{ABDC83D6-2C92-BD3E-BEE5-09B26769E038}"/>
+              </a:ext>
+            </a:extLst>
+          </p:cNvPr>
+          <p:cNvSpPr/>
+          <p:nvPr/>
+        </p:nvSpPr>
+        <p:spPr>
+          <a:xfrm>
+            <a:off x="193511" y="862840"/>
+            <a:ext cx="294870" cy="294870"/>
+          </a:xfrm>
+          <a:prstGeom prst="ellipse">
+            <a:avLst/>
+          </a:prstGeom>
+        </p:spPr>
+        <p:style>
+          <a:lnRef idx="2">
+            <a:schemeClr val="accent1">
+              <a:shade val="15000"/>
+            </a:schemeClr>
+          </a:lnRef>
+          <a:fillRef idx="1">
+            <a:schemeClr val="accent1"/>
+          </a:fillRef>
+          <a:effectRef idx="0">
+            <a:schemeClr val="accent1"/>
+          </a:effectRef>
+          <a:fontRef idx="minor">
+            <a:schemeClr val="lt1"/>
+          </a:fontRef>
+        </p:style>
+        <p:txBody>
+          <a:bodyPr rtlCol="0" anchor="ctr"/>
+          <a:lstStyle/>
+          <a:p>
+            <a:pPr algn="ctr"/>
+            <a:r>
+              <a:rPr lang="en-US" altLang="ko-KR" dirty="0"/>
+              <a:t>1</a:t>
+            </a:r>
+            <a:endParaRPr lang="ko-KR" altLang="en-US" dirty="0"/>
+          </a:p>
+        </p:txBody>
+      </p:sp>
+      <p:sp>
+        <p:nvSpPr>
+          <p:cNvPr id="32" name="타원 31">
+            <a:extLst>
+              <a:ext uri="{FF2B5EF4-FFF2-40B4-BE49-F238E27FC236}">
+                <a16:creationId xmlns:a16="http://schemas.microsoft.com/office/drawing/2014/main" id="{382E55A1-5962-180A-917E-0A78F25711AC}"/>
+              </a:ext>
+            </a:extLst>
+          </p:cNvPr>
+          <p:cNvSpPr/>
+          <p:nvPr/>
+        </p:nvSpPr>
+        <p:spPr>
+          <a:xfrm>
+            <a:off x="262177" y="3703811"/>
+            <a:ext cx="294870" cy="294870"/>
+          </a:xfrm>
+          <a:prstGeom prst="ellipse">
+            <a:avLst/>
+          </a:prstGeom>
+        </p:spPr>
+        <p:style>
+          <a:lnRef idx="2">
+            <a:schemeClr val="accent1">
+              <a:shade val="15000"/>
+            </a:schemeClr>
+          </a:lnRef>
+          <a:fillRef idx="1">
+            <a:schemeClr val="accent1"/>
+          </a:fillRef>
+          <a:effectRef idx="0">
+            <a:schemeClr val="accent1"/>
+          </a:effectRef>
+          <a:fontRef idx="minor">
+            <a:schemeClr val="lt1"/>
+          </a:fontRef>
+        </p:style>
+        <p:txBody>
+          <a:bodyPr rtlCol="0" anchor="ctr"/>
+          <a:lstStyle/>
+          <a:p>
+            <a:pPr algn="ctr"/>
+            <a:r>
+              <a:rPr lang="en-US" altLang="ko-KR" dirty="0"/>
+              <a:t>2</a:t>
+            </a:r>
+            <a:endParaRPr lang="ko-KR" altLang="en-US" dirty="0"/>
+          </a:p>
+        </p:txBody>
+      </p:sp>
+      <p:sp>
+        <p:nvSpPr>
+          <p:cNvPr id="33" name="타원 32">
+            <a:extLst>
+              <a:ext uri="{FF2B5EF4-FFF2-40B4-BE49-F238E27FC236}">
+                <a16:creationId xmlns:a16="http://schemas.microsoft.com/office/drawing/2014/main" id="{1A2F855D-672F-CDE6-8312-F837EE6805E5}"/>
+              </a:ext>
+            </a:extLst>
+          </p:cNvPr>
+          <p:cNvSpPr/>
+          <p:nvPr/>
+        </p:nvSpPr>
+        <p:spPr>
+          <a:xfrm>
+            <a:off x="3765903" y="98719"/>
+            <a:ext cx="294870" cy="294870"/>
+          </a:xfrm>
+          <a:prstGeom prst="ellipse">
+            <a:avLst/>
+          </a:prstGeom>
+        </p:spPr>
+        <p:style>
+          <a:lnRef idx="2">
+            <a:schemeClr val="accent1">
+              <a:shade val="15000"/>
+            </a:schemeClr>
+          </a:lnRef>
+          <a:fillRef idx="1">
+            <a:schemeClr val="accent1"/>
+          </a:fillRef>
+          <a:effectRef idx="0">
+            <a:schemeClr val="accent1"/>
+          </a:effectRef>
+          <a:fontRef idx="minor">
+            <a:schemeClr val="lt1"/>
+          </a:fontRef>
+        </p:style>
+        <p:txBody>
+          <a:bodyPr rtlCol="0" anchor="ctr"/>
+          <a:lstStyle/>
+          <a:p>
+            <a:pPr algn="ctr"/>
+            <a:r>
+              <a:rPr lang="en-US" altLang="ko-KR" dirty="0"/>
+              <a:t>3</a:t>
+            </a:r>
+            <a:endParaRPr lang="ko-KR" altLang="en-US" dirty="0"/>
+          </a:p>
+        </p:txBody>
+      </p:sp>
+      <p:sp>
+        <p:nvSpPr>
+          <p:cNvPr id="14" name="TextBox 13">
+            <a:extLst>
+              <a:ext uri="{FF2B5EF4-FFF2-40B4-BE49-F238E27FC236}">
+                <a16:creationId xmlns:a16="http://schemas.microsoft.com/office/drawing/2014/main" id="{A057DDBF-B132-F1DF-29DC-89B36A45AEEC}"/>
+              </a:ext>
+            </a:extLst>
+          </p:cNvPr>
+          <p:cNvSpPr txBox="1"/>
+          <p:nvPr/>
+        </p:nvSpPr>
+        <p:spPr>
+          <a:xfrm>
+            <a:off x="59685" y="6180115"/>
+            <a:ext cx="3574490" cy="461665"/>
+          </a:xfrm>
+          <a:prstGeom prst="rect">
+            <a:avLst/>
+          </a:prstGeom>
+          <a:noFill/>
+        </p:spPr>
+        <p:txBody>
+          <a:bodyPr wrap="square">
+            <a:spAutoFit/>
+          </a:bodyPr>
+          <a:lstStyle/>
+          <a:p>
+            <a:pPr algn="ctr"/>
+            <a:r>
+              <a:rPr lang="ko-KR" altLang="en-US" sz="1200" dirty="0"/>
+              <a:t>정보를 가져오기 위해 필요한 항목들이라 </a:t>
+            </a:r>
+            <a:endParaRPr lang="en-US" altLang="ko-KR" sz="1200" dirty="0"/>
+          </a:p>
+          <a:p>
+            <a:pPr algn="ctr"/>
+            <a:r>
+              <a:rPr lang="ko-KR" altLang="en-US" sz="1200" dirty="0"/>
+              <a:t>전부 동의하셔야 서비스 이용이 가능합니다 </a:t>
+            </a:r>
+          </a:p>
+        </p:txBody>
+      </p:sp>
+      <p:sp>
+        <p:nvSpPr>
+          <p:cNvPr id="15" name="TextBox 14">
+            <a:extLst>
+              <a:ext uri="{FF2B5EF4-FFF2-40B4-BE49-F238E27FC236}">
+                <a16:creationId xmlns:a16="http://schemas.microsoft.com/office/drawing/2014/main" id="{153C0C33-E6FE-4E12-6FB1-3E0309AA1849}"/>
+              </a:ext>
+            </a:extLst>
+          </p:cNvPr>
+          <p:cNvSpPr txBox="1"/>
+          <p:nvPr/>
+        </p:nvSpPr>
+        <p:spPr>
+          <a:xfrm>
+            <a:off x="190385" y="216220"/>
+            <a:ext cx="2662908" cy="523220"/>
+          </a:xfrm>
+          <a:prstGeom prst="rect">
+            <a:avLst/>
+          </a:prstGeom>
+          <a:noFill/>
+        </p:spPr>
+        <p:txBody>
+          <a:bodyPr wrap="none" rtlCol="0">
+            <a:spAutoFit/>
+          </a:bodyPr>
+          <a:lstStyle/>
+          <a:p>
+            <a:r>
+              <a:rPr lang="en-US" altLang="ko-KR" sz="2800" b="1" dirty="0"/>
+              <a:t>2. </a:t>
+            </a:r>
+            <a:r>
+              <a:rPr lang="ko-KR" altLang="en-US" sz="2800" b="1" dirty="0"/>
+              <a:t>독 사용 방법</a:t>
+            </a:r>
+          </a:p>
+        </p:txBody>
+      </p:sp>
+      <p:sp>
+        <p:nvSpPr>
+          <p:cNvPr id="16" name="TextBox 15">
+            <a:extLst>
+              <a:ext uri="{FF2B5EF4-FFF2-40B4-BE49-F238E27FC236}">
+                <a16:creationId xmlns:a16="http://schemas.microsoft.com/office/drawing/2014/main" id="{E4B31753-C55F-E607-0CC7-0F24943073B7}"/>
+              </a:ext>
+            </a:extLst>
+          </p:cNvPr>
+          <p:cNvSpPr txBox="1"/>
+          <p:nvPr/>
+        </p:nvSpPr>
+        <p:spPr>
+          <a:xfrm>
+            <a:off x="8938302" y="880711"/>
+            <a:ext cx="2857503" cy="276999"/>
+          </a:xfrm>
+          <a:prstGeom prst="rect">
+            <a:avLst/>
+          </a:prstGeom>
+          <a:noFill/>
+        </p:spPr>
+        <p:txBody>
+          <a:bodyPr wrap="square">
+            <a:spAutoFit/>
+          </a:bodyPr>
+          <a:lstStyle/>
+          <a:p>
+            <a:r>
+              <a:rPr lang="ko-KR" altLang="en-US" sz="1200"/>
+              <a:t>현재 방송 제목 조회 및 변경 가능</a:t>
+            </a:r>
+            <a:endParaRPr lang="ko-KR" altLang="en-US" sz="1200" dirty="0"/>
+          </a:p>
+        </p:txBody>
+      </p:sp>
+      <p:cxnSp>
+        <p:nvCxnSpPr>
+          <p:cNvPr id="19" name="직선 화살표 연결선 18">
+            <a:extLst>
+              <a:ext uri="{FF2B5EF4-FFF2-40B4-BE49-F238E27FC236}">
+                <a16:creationId xmlns:a16="http://schemas.microsoft.com/office/drawing/2014/main" id="{7E3AEAD5-D422-92AA-5E6E-23988CF9C030}"/>
+              </a:ext>
+            </a:extLst>
+          </p:cNvPr>
+          <p:cNvCxnSpPr>
+            <a:endCxn id="16" idx="1"/>
+          </p:cNvCxnSpPr>
+          <p:nvPr/>
+        </p:nvCxnSpPr>
+        <p:spPr>
+          <a:xfrm flipV="1">
+            <a:off x="8125691" y="1019211"/>
+            <a:ext cx="812611" cy="373171"/>
+          </a:xfrm>
+          <a:prstGeom prst="straightConnector1">
+            <a:avLst/>
+          </a:prstGeom>
+          <a:ln w="28575">
+            <a:solidFill>
+              <a:srgbClr val="FF0000"/>
+            </a:solidFill>
+            <a:tailEnd type="triangle"/>
+          </a:ln>
+        </p:spPr>
+        <p:style>
+          <a:lnRef idx="1">
+            <a:schemeClr val="accent1"/>
+          </a:lnRef>
+          <a:fillRef idx="0">
+            <a:schemeClr val="accent1"/>
+          </a:fillRef>
+          <a:effectRef idx="0">
+            <a:schemeClr val="accent1"/>
+          </a:effectRef>
+          <a:fontRef idx="minor">
+            <a:schemeClr val="tx1"/>
+          </a:fontRef>
+        </p:style>
+      </p:cxnSp>
+      <p:cxnSp>
+        <p:nvCxnSpPr>
+          <p:cNvPr id="20" name="직선 화살표 연결선 19">
+            <a:extLst>
+              <a:ext uri="{FF2B5EF4-FFF2-40B4-BE49-F238E27FC236}">
+                <a16:creationId xmlns:a16="http://schemas.microsoft.com/office/drawing/2014/main" id="{C1A1AC31-93CE-F148-A711-C56948CC5679}"/>
+              </a:ext>
+            </a:extLst>
+          </p:cNvPr>
+          <p:cNvCxnSpPr>
+            <a:cxnSpLocks/>
+            <a:endCxn id="23" idx="1"/>
+          </p:cNvCxnSpPr>
+          <p:nvPr/>
+        </p:nvCxnSpPr>
+        <p:spPr>
+          <a:xfrm flipV="1">
+            <a:off x="8098723" y="1669382"/>
+            <a:ext cx="839578" cy="401946"/>
+          </a:xfrm>
+          <a:prstGeom prst="straightConnector1">
+            <a:avLst/>
+          </a:prstGeom>
+          <a:ln w="28575">
+            <a:solidFill>
+              <a:srgbClr val="FF0000"/>
+            </a:solidFill>
+            <a:tailEnd type="triangle"/>
+          </a:ln>
+        </p:spPr>
+        <p:style>
+          <a:lnRef idx="1">
+            <a:schemeClr val="accent1"/>
+          </a:lnRef>
+          <a:fillRef idx="0">
+            <a:schemeClr val="accent1"/>
+          </a:fillRef>
+          <a:effectRef idx="0">
+            <a:schemeClr val="accent1"/>
+          </a:effectRef>
+          <a:fontRef idx="minor">
+            <a:schemeClr val="tx1"/>
+          </a:fontRef>
+        </p:style>
+      </p:cxnSp>
+      <p:sp>
+        <p:nvSpPr>
+          <p:cNvPr id="23" name="TextBox 22">
+            <a:extLst>
+              <a:ext uri="{FF2B5EF4-FFF2-40B4-BE49-F238E27FC236}">
+                <a16:creationId xmlns:a16="http://schemas.microsoft.com/office/drawing/2014/main" id="{4D862594-7EEA-4579-95D4-A284D1D77A70}"/>
+              </a:ext>
+            </a:extLst>
+          </p:cNvPr>
+          <p:cNvSpPr txBox="1"/>
+          <p:nvPr/>
+        </p:nvSpPr>
+        <p:spPr>
+          <a:xfrm>
+            <a:off x="8938301" y="1530882"/>
+            <a:ext cx="2857503" cy="276999"/>
+          </a:xfrm>
+          <a:prstGeom prst="rect">
+            <a:avLst/>
+          </a:prstGeom>
+          <a:noFill/>
+        </p:spPr>
+        <p:txBody>
+          <a:bodyPr wrap="square">
+            <a:spAutoFit/>
+          </a:bodyPr>
+          <a:lstStyle/>
+          <a:p>
+            <a:r>
+              <a:rPr lang="ko-KR" altLang="en-US" sz="1200"/>
+              <a:t>현재 카테고리 조회 및 변경 가능</a:t>
+            </a:r>
+            <a:endParaRPr lang="ko-KR" altLang="en-US" sz="1200" dirty="0"/>
+          </a:p>
+        </p:txBody>
+      </p:sp>
+      <p:sp>
+        <p:nvSpPr>
+          <p:cNvPr id="25" name="TextBox 24">
+            <a:extLst>
+              <a:ext uri="{FF2B5EF4-FFF2-40B4-BE49-F238E27FC236}">
+                <a16:creationId xmlns:a16="http://schemas.microsoft.com/office/drawing/2014/main" id="{553C6F3F-565D-8DAD-FF4E-3F6E996E0BA1}"/>
+              </a:ext>
+            </a:extLst>
+          </p:cNvPr>
+          <p:cNvSpPr txBox="1"/>
+          <p:nvPr/>
+        </p:nvSpPr>
+        <p:spPr>
+          <a:xfrm>
+            <a:off x="9003817" y="3355260"/>
+            <a:ext cx="2857503" cy="276999"/>
+          </a:xfrm>
+          <a:prstGeom prst="rect">
+            <a:avLst/>
+          </a:prstGeom>
+          <a:noFill/>
+        </p:spPr>
+        <p:txBody>
+          <a:bodyPr wrap="square">
+            <a:spAutoFit/>
+          </a:bodyPr>
+          <a:lstStyle/>
+          <a:p>
+            <a:r>
+              <a:rPr lang="ko-KR" altLang="en-US" sz="1200" dirty="0"/>
+              <a:t>카테고리 검색하여 적용 가능</a:t>
+            </a:r>
+          </a:p>
+        </p:txBody>
+      </p:sp>
+      <p:cxnSp>
+        <p:nvCxnSpPr>
+          <p:cNvPr id="28" name="직선 화살표 연결선 27">
+            <a:extLst>
+              <a:ext uri="{FF2B5EF4-FFF2-40B4-BE49-F238E27FC236}">
+                <a16:creationId xmlns:a16="http://schemas.microsoft.com/office/drawing/2014/main" id="{258405D6-B103-4306-0CF3-678C35DB1A59}"/>
+              </a:ext>
+            </a:extLst>
+          </p:cNvPr>
+          <p:cNvCxnSpPr>
+            <a:cxnSpLocks/>
+            <a:endCxn id="34" idx="1"/>
+          </p:cNvCxnSpPr>
+          <p:nvPr/>
+        </p:nvCxnSpPr>
+        <p:spPr>
+          <a:xfrm>
+            <a:off x="8301876" y="3210862"/>
+            <a:ext cx="701941" cy="879468"/>
+          </a:xfrm>
+          <a:prstGeom prst="straightConnector1">
+            <a:avLst/>
+          </a:prstGeom>
+          <a:ln w="28575">
+            <a:solidFill>
+              <a:srgbClr val="FF0000"/>
+            </a:solidFill>
+            <a:tailEnd type="triangle"/>
+          </a:ln>
+        </p:spPr>
+        <p:style>
+          <a:lnRef idx="1">
+            <a:schemeClr val="accent1"/>
+          </a:lnRef>
+          <a:fillRef idx="0">
+            <a:schemeClr val="accent1"/>
+          </a:fillRef>
+          <a:effectRef idx="0">
+            <a:schemeClr val="accent1"/>
+          </a:effectRef>
+          <a:fontRef idx="minor">
+            <a:schemeClr val="tx1"/>
+          </a:fontRef>
+        </p:style>
+      </p:cxnSp>
+      <p:sp>
+        <p:nvSpPr>
+          <p:cNvPr id="34" name="TextBox 33">
+            <a:extLst>
+              <a:ext uri="{FF2B5EF4-FFF2-40B4-BE49-F238E27FC236}">
+                <a16:creationId xmlns:a16="http://schemas.microsoft.com/office/drawing/2014/main" id="{32732FBD-D33F-BC89-724C-688AF76D7F45}"/>
+              </a:ext>
+            </a:extLst>
+          </p:cNvPr>
+          <p:cNvSpPr txBox="1"/>
+          <p:nvPr/>
+        </p:nvSpPr>
+        <p:spPr>
+          <a:xfrm>
+            <a:off x="9003817" y="3951830"/>
+            <a:ext cx="2857503" cy="276999"/>
+          </a:xfrm>
+          <a:prstGeom prst="rect">
+            <a:avLst/>
+          </a:prstGeom>
+          <a:noFill/>
+        </p:spPr>
+        <p:txBody>
+          <a:bodyPr wrap="square">
+            <a:spAutoFit/>
+          </a:bodyPr>
+          <a:lstStyle/>
+          <a:p>
+            <a:r>
+              <a:rPr lang="ko-KR" altLang="en-US" sz="1200" dirty="0"/>
+              <a:t>현재 태그 조회 및 변경 가능</a:t>
+            </a:r>
+          </a:p>
+        </p:txBody>
+      </p:sp>
+      <p:cxnSp>
+        <p:nvCxnSpPr>
+          <p:cNvPr id="37" name="직선 화살표 연결선 36">
+            <a:extLst>
+              <a:ext uri="{FF2B5EF4-FFF2-40B4-BE49-F238E27FC236}">
+                <a16:creationId xmlns:a16="http://schemas.microsoft.com/office/drawing/2014/main" id="{3BEFD4DD-D3F9-9B32-1FA2-E64E8A4A43DE}"/>
+              </a:ext>
+            </a:extLst>
+          </p:cNvPr>
+          <p:cNvCxnSpPr>
+            <a:cxnSpLocks/>
+            <a:endCxn id="38" idx="1"/>
+          </p:cNvCxnSpPr>
+          <p:nvPr/>
+        </p:nvCxnSpPr>
+        <p:spPr>
+          <a:xfrm>
+            <a:off x="8125691" y="4498868"/>
+            <a:ext cx="878126" cy="546345"/>
+          </a:xfrm>
+          <a:prstGeom prst="straightConnector1">
+            <a:avLst/>
+          </a:prstGeom>
+          <a:ln w="28575">
+            <a:solidFill>
+              <a:srgbClr val="FF0000"/>
+            </a:solidFill>
+            <a:tailEnd type="triangle"/>
+          </a:ln>
+        </p:spPr>
+        <p:style>
+          <a:lnRef idx="1">
+            <a:schemeClr val="accent1"/>
+          </a:lnRef>
+          <a:fillRef idx="0">
+            <a:schemeClr val="accent1"/>
+          </a:fillRef>
+          <a:effectRef idx="0">
+            <a:schemeClr val="accent1"/>
+          </a:effectRef>
+          <a:fontRef idx="minor">
+            <a:schemeClr val="tx1"/>
+          </a:fontRef>
+        </p:style>
+      </p:cxnSp>
+      <p:sp>
+        <p:nvSpPr>
+          <p:cNvPr id="38" name="TextBox 37">
+            <a:extLst>
+              <a:ext uri="{FF2B5EF4-FFF2-40B4-BE49-F238E27FC236}">
+                <a16:creationId xmlns:a16="http://schemas.microsoft.com/office/drawing/2014/main" id="{98875A8A-4459-DC41-3147-6BD7E97C6E73}"/>
+              </a:ext>
+            </a:extLst>
+          </p:cNvPr>
+          <p:cNvSpPr txBox="1"/>
+          <p:nvPr/>
+        </p:nvSpPr>
+        <p:spPr>
+          <a:xfrm>
+            <a:off x="9003817" y="4629714"/>
+            <a:ext cx="3188183" cy="830997"/>
+          </a:xfrm>
+          <a:prstGeom prst="rect">
+            <a:avLst/>
+          </a:prstGeom>
+          <a:noFill/>
+        </p:spPr>
+        <p:txBody>
+          <a:bodyPr wrap="square">
+            <a:spAutoFit/>
+          </a:bodyPr>
+          <a:lstStyle/>
+          <a:p>
+            <a:r>
+              <a:rPr lang="ko-KR" altLang="en-US" sz="1200" dirty="0"/>
+              <a:t>동시시청장</a:t>
+            </a:r>
+            <a:r>
+              <a:rPr lang="en-US" altLang="ko-KR" sz="1200" dirty="0"/>
+              <a:t>, </a:t>
+            </a:r>
+            <a:r>
+              <a:rPr lang="ko-KR" altLang="en-US" sz="1200" dirty="0"/>
+              <a:t>최고시청자</a:t>
+            </a:r>
+            <a:r>
+              <a:rPr lang="en-US" altLang="ko-KR" sz="1200" dirty="0"/>
+              <a:t>, </a:t>
+            </a:r>
+            <a:r>
+              <a:rPr lang="ko-KR" altLang="en-US" sz="1200" dirty="0"/>
+              <a:t>평균시청자</a:t>
+            </a:r>
+            <a:r>
+              <a:rPr lang="en-US" altLang="ko-KR" sz="1200" dirty="0"/>
+              <a:t>, </a:t>
+            </a:r>
+            <a:r>
+              <a:rPr lang="ko-KR" altLang="en-US" sz="1200" dirty="0" err="1"/>
+              <a:t>팔로워</a:t>
+            </a:r>
+            <a:r>
+              <a:rPr lang="ko-KR" altLang="en-US" sz="1200" dirty="0"/>
+              <a:t> 실시간 조회 가능</a:t>
+            </a:r>
+            <a:endParaRPr lang="en-US" altLang="ko-KR" sz="1200" dirty="0"/>
+          </a:p>
+          <a:p>
+            <a:endParaRPr lang="en-US" altLang="ko-KR" sz="1200" dirty="0"/>
+          </a:p>
+          <a:p>
+            <a:r>
+              <a:rPr lang="ko-KR" altLang="en-US" sz="1200" dirty="0"/>
+              <a:t>클릭 시 가림 기능</a:t>
+            </a:r>
+          </a:p>
+        </p:txBody>
+      </p:sp>
+      <p:sp>
+        <p:nvSpPr>
+          <p:cNvPr id="40" name="TextBox 39">
+            <a:extLst>
+              <a:ext uri="{FF2B5EF4-FFF2-40B4-BE49-F238E27FC236}">
+                <a16:creationId xmlns:a16="http://schemas.microsoft.com/office/drawing/2014/main" id="{C2511B67-3C5D-B6CB-76FD-D91622D1DDD5}"/>
+              </a:ext>
+            </a:extLst>
+          </p:cNvPr>
+          <p:cNvSpPr txBox="1"/>
+          <p:nvPr/>
+        </p:nvSpPr>
+        <p:spPr>
+          <a:xfrm>
+            <a:off x="9003817" y="6019754"/>
+            <a:ext cx="2857503" cy="276999"/>
+          </a:xfrm>
+          <a:prstGeom prst="rect">
+            <a:avLst/>
+          </a:prstGeom>
+          <a:noFill/>
+        </p:spPr>
+        <p:txBody>
+          <a:bodyPr wrap="square">
+            <a:spAutoFit/>
+          </a:bodyPr>
+          <a:lstStyle/>
+          <a:p>
+            <a:r>
+              <a:rPr lang="ko-KR" altLang="en-US" sz="1200"/>
+              <a:t>로그아웃 하여 연동 해제</a:t>
+            </a:r>
+            <a:endParaRPr lang="ko-KR" altLang="en-US" sz="1200" dirty="0"/>
+          </a:p>
+        </p:txBody>
+      </p:sp>
+      <p:cxnSp>
+        <p:nvCxnSpPr>
+          <p:cNvPr id="41" name="직선 화살표 연결선 40">
+            <a:extLst>
+              <a:ext uri="{FF2B5EF4-FFF2-40B4-BE49-F238E27FC236}">
+                <a16:creationId xmlns:a16="http://schemas.microsoft.com/office/drawing/2014/main" id="{DAF01846-582F-A9EE-B2A2-F120AFA4BAC6}"/>
+              </a:ext>
+            </a:extLst>
+          </p:cNvPr>
+          <p:cNvCxnSpPr>
+            <a:cxnSpLocks/>
+            <a:endCxn id="40" idx="1"/>
+          </p:cNvCxnSpPr>
+          <p:nvPr/>
+        </p:nvCxnSpPr>
+        <p:spPr>
+          <a:xfrm>
+            <a:off x="8301876" y="6158254"/>
+            <a:ext cx="701941" cy="0"/>
+          </a:xfrm>
+          <a:prstGeom prst="straightConnector1">
+            <a:avLst/>
+          </a:prstGeom>
+          <a:ln w="28575">
+            <a:solidFill>
+              <a:srgbClr val="FF0000"/>
+            </a:solidFill>
+            <a:tailEnd type="triangle"/>
+          </a:ln>
+        </p:spPr>
+        <p:style>
+          <a:lnRef idx="1">
+            <a:schemeClr val="accent1"/>
+          </a:lnRef>
+          <a:fillRef idx="0">
+            <a:schemeClr val="accent1"/>
+          </a:fillRef>
+          <a:effectRef idx="0">
+            <a:schemeClr val="accent1"/>
+          </a:effectRef>
+          <a:fontRef idx="minor">
+            <a:schemeClr val="tx1"/>
+          </a:fontRef>
+        </p:style>
+      </p:cxnSp>
+    </p:spTree>
+    <p:extLst>
+      <p:ext uri="{BB962C8B-B14F-4D97-AF65-F5344CB8AC3E}">
+        <p14:creationId xmlns:p14="http://schemas.microsoft.com/office/powerpoint/2010/main" val="2732685688"/>
       </p:ext>
     </p:extLst>
   </p:cSld>

</xml_diff>